<commit_message>
updated / added bachlor thesis kolloquium presentation
</commit_message>
<xml_diff>
--- a/Presentation/TheoriePraxisTransfer.pptx
+++ b/Presentation/TheoriePraxisTransfer.pptx
@@ -305,7 +305,7 @@
             </a:pPr>
             <a:fld id="{CBD6B031-F9E6-4257-BEFE-97AC0BFD9929}" type="datetime1">
               <a:rPr lang="de-DE" smtClean="0"/>
-              <a:t>07.08.2026</a:t>
+              <a:t>13.08.2026</a:t>
             </a:fld>
             <a:endParaRPr lang="de-DE"/>
           </a:p>
@@ -537,7 +537,7 @@
             </a:pPr>
             <a:fld id="{E137B09C-7F70-4F9A-A900-E88478135E06}" type="datetime1">
               <a:rPr lang="de-DE" smtClean="0"/>
-              <a:t>07.08.2026</a:t>
+              <a:t>12.08.2026</a:t>
             </a:fld>
             <a:endParaRPr lang="de-DE"/>
           </a:p>
@@ -953,7 +953,7 @@
             </a:pPr>
             <a:fld id="{C7B72803-4596-439A-A1FF-AE633C68A548}" type="datetime1">
               <a:rPr lang="de-DE" smtClean="0"/>
-              <a:t>07.08.2026</a:t>
+              <a:t>12.08.2026</a:t>
             </a:fld>
             <a:endParaRPr lang="de-DE"/>
           </a:p>
@@ -1346,7 +1346,7 @@
             </a:pPr>
             <a:fld id="{5CC56EBC-D08B-471E-ACE4-D1109E130940}" type="datetime1">
               <a:rPr lang="de-DE" smtClean="0"/>
-              <a:t>07.08.2026</a:t>
+              <a:t>12.08.2026</a:t>
             </a:fld>
             <a:endParaRPr lang="de-DE" dirty="0"/>
           </a:p>
@@ -1904,7 +1904,7 @@
             </a:pPr>
             <a:fld id="{B080BB7F-5BF7-42B1-9AEF-6AC89BF92477}" type="datetime1">
               <a:rPr lang="de-DE" smtClean="0"/>
-              <a:t>07.08.2026</a:t>
+              <a:t>12.08.2026</a:t>
             </a:fld>
             <a:endParaRPr lang="de-DE" dirty="0"/>
           </a:p>
@@ -2066,7 +2066,7 @@
             </a:pPr>
             <a:fld id="{CD27EF17-2B2B-4FEC-8EC5-D78394CCC2F2}" type="datetime1">
               <a:rPr lang="de-DE" smtClean="0"/>
-              <a:t>07.08.2026</a:t>
+              <a:t>12.08.2026</a:t>
             </a:fld>
             <a:endParaRPr lang="de-DE" dirty="0"/>
           </a:p>
@@ -2873,7 +2873,7 @@
             </a:pPr>
             <a:fld id="{4C110744-78DB-4CCD-A5E8-96EE1214D9B7}" type="datetime1">
               <a:rPr lang="de-DE" smtClean="0"/>
-              <a:t>07.08.2026</a:t>
+              <a:t>12.08.2026</a:t>
             </a:fld>
             <a:endParaRPr lang="de-DE" dirty="0"/>
           </a:p>
@@ -3651,7 +3651,7 @@
             </a:pPr>
             <a:fld id="{3C29F121-C0AB-4DB3-BEE4-C25B75C4FBBF}" type="datetime1">
               <a:rPr lang="de-DE" smtClean="0"/>
-              <a:t>07.08.2026</a:t>
+              <a:t>12.08.2026</a:t>
             </a:fld>
             <a:endParaRPr lang="de-DE" dirty="0"/>
           </a:p>
@@ -4919,7 +4919,7 @@
             </a:pPr>
             <a:fld id="{50A682CC-0F99-4099-8894-018C221C7E76}" type="datetime1">
               <a:rPr lang="de-DE" smtClean="0"/>
-              <a:t>07.08.2026</a:t>
+              <a:t>12.08.2026</a:t>
             </a:fld>
             <a:endParaRPr lang="de-DE" dirty="0"/>
           </a:p>
@@ -6322,7 +6322,7 @@
             </a:pPr>
             <a:fld id="{83722A70-79C5-4CD6-9DF2-113901699198}" type="datetime1">
               <a:rPr lang="de-DE" noProof="0" smtClean="0"/>
-              <a:t>07.08.2026</a:t>
+              <a:t>12.08.2026</a:t>
             </a:fld>
             <a:endParaRPr lang="de-DE" noProof="0" dirty="0"/>
           </a:p>
@@ -6552,6 +6552,10 @@
           </p:nvPr>
         </p:nvSpPr>
         <p:spPr>
+          <a:xfrm>
+            <a:off x="6827434" y="347090"/>
+            <a:ext cx="1524000" cy="283234"/>
+          </a:xfrm>
           <a:prstGeom prst="rect">
             <a:avLst/>
           </a:prstGeom>
@@ -6627,7 +6631,7 @@
             </a:pPr>
             <a:fld id="{8F88511F-0DED-4754-8AED-059212722EAC}" type="datetime1">
               <a:rPr lang="de-DE" noProof="0" smtClean="0"/>
-              <a:t>07.08.2026</a:t>
+              <a:t>12.08.2026</a:t>
             </a:fld>
             <a:endParaRPr lang="de-DE" noProof="0" dirty="0"/>
           </a:p>
@@ -6672,14 +6676,14 @@
           <p:nvPr>
             <p:extLst>
               <p:ext uri="{D42A27DB-BD31-4B8C-83A1-F6EECF244321}">
-                <p14:modId xmlns:p14="http://schemas.microsoft.com/office/powerpoint/2010/main" val="1078444929"/>
+                <p14:modId xmlns:p14="http://schemas.microsoft.com/office/powerpoint/2010/main" val="4178256805"/>
               </p:ext>
             </p:extLst>
           </p:nvPr>
         </p:nvGraphicFramePr>
         <p:xfrm>
           <a:off x="141276" y="1383557"/>
-          <a:ext cx="6045967" cy="3680586"/>
+          <a:ext cx="8692886" cy="3680586"/>
         </p:xfrm>
         <a:graphic>
           <a:graphicData uri="http://schemas.openxmlformats.org/drawingml/2006/table">
@@ -6688,17 +6692,24 @@
                 <a:tableStyleId>{5C22544A-7EE6-4342-B048-85BDC9FD1C3A}</a:tableStyleId>
               </a:tblPr>
               <a:tblGrid>
-                <a:gridCol w="372540">
+                <a:gridCol w="523742">
                   <a:extLst>
                     <a:ext uri="{9D8B030D-6E8A-4147-A177-3AD203B41FA5}">
                       <a16:colId xmlns:a16="http://schemas.microsoft.com/office/drawing/2014/main" val="20000"/>
                     </a:ext>
                   </a:extLst>
                 </a:gridCol>
-                <a:gridCol w="5673427">
+                <a:gridCol w="7458784">
                   <a:extLst>
                     <a:ext uri="{9D8B030D-6E8A-4147-A177-3AD203B41FA5}">
                       <a16:colId xmlns:a16="http://schemas.microsoft.com/office/drawing/2014/main" val="20001"/>
+                    </a:ext>
+                  </a:extLst>
+                </a:gridCol>
+                <a:gridCol w="710360">
+                  <a:extLst>
+                    <a:ext uri="{9D8B030D-6E8A-4147-A177-3AD203B41FA5}">
+                      <a16:colId xmlns:a16="http://schemas.microsoft.com/office/drawing/2014/main" val="1653140279"/>
                     </a:ext>
                   </a:extLst>
                 </a:gridCol>
@@ -6915,6 +6926,37 @@
                           </a:solidFill>
                         </a:rPr>
                         <a:t>Über mich</a:t>
+                      </a:r>
+                    </a:p>
+                  </a:txBody>
+                  <a:tcPr marL="70092" marR="70092" marT="0" marB="0" anchor="ctr">
+                    <a:solidFill>
+                      <a:schemeClr val="bg1">
+                        <a:lumMod val="95000"/>
+                      </a:schemeClr>
+                    </a:solidFill>
+                  </a:tcPr>
+                </a:tc>
+                <a:tc>
+                  <a:txBody>
+                    <a:bodyPr/>
+                    <a:lstStyle/>
+                    <a:p>
+                      <a:pPr algn="l">
+                        <a:spcBef>
+                          <a:spcPts val="1200"/>
+                        </a:spcBef>
+                        <a:spcAft>
+                          <a:spcPts val="0"/>
+                        </a:spcAft>
+                      </a:pPr>
+                      <a:r>
+                        <a:rPr lang="de-DE" sz="1600" b="0" noProof="0" dirty="0">
+                          <a:solidFill>
+                            <a:schemeClr val="tx1"/>
+                          </a:solidFill>
+                        </a:rPr>
+                        <a:t>4</a:t>
                       </a:r>
                     </a:p>
                   </a:txBody>
@@ -7158,6 +7200,42 @@
                     </a:solidFill>
                   </a:tcPr>
                 </a:tc>
+                <a:tc>
+                  <a:txBody>
+                    <a:bodyPr/>
+                    <a:lstStyle/>
+                    <a:p>
+                      <a:pPr algn="l">
+                        <a:spcBef>
+                          <a:spcPts val="1200"/>
+                        </a:spcBef>
+                        <a:spcAft>
+                          <a:spcPts val="0"/>
+                        </a:spcAft>
+                      </a:pPr>
+                      <a:r>
+                        <a:rPr lang="de-DE" sz="1600" b="0" noProof="0" dirty="0">
+                          <a:solidFill>
+                            <a:schemeClr val="tx2">
+                              <a:lumMod val="50000"/>
+                            </a:schemeClr>
+                          </a:solidFill>
+                          <a:latin typeface="Arial"/>
+                          <a:ea typeface="Times New Roman"/>
+                          <a:cs typeface="Times New Roman"/>
+                        </a:rPr>
+                        <a:t>5</a:t>
+                      </a:r>
+                    </a:p>
+                  </a:txBody>
+                  <a:tcPr marL="70092" marR="70092" marT="0" marB="0" anchor="ctr">
+                    <a:solidFill>
+                      <a:schemeClr val="bg1">
+                        <a:lumMod val="95000"/>
+                      </a:schemeClr>
+                    </a:solidFill>
+                  </a:tcPr>
+                </a:tc>
                 <a:extLst>
                   <a:ext uri="{0D108BD9-81ED-4DB2-BD59-A6C34878D82A}">
                     <a16:rowId xmlns:a16="http://schemas.microsoft.com/office/drawing/2014/main" val="10001"/>
@@ -7373,6 +7451,39 @@
                           <a:cs typeface="Times New Roman"/>
                         </a:rPr>
                         <a:t>Theorie ↔ Praxis</a:t>
+                      </a:r>
+                    </a:p>
+                  </a:txBody>
+                  <a:tcPr marL="70092" marR="70092" marT="0" marB="0" anchor="ctr">
+                    <a:solidFill>
+                      <a:schemeClr val="bg1">
+                        <a:lumMod val="95000"/>
+                      </a:schemeClr>
+                    </a:solidFill>
+                  </a:tcPr>
+                </a:tc>
+                <a:tc>
+                  <a:txBody>
+                    <a:bodyPr/>
+                    <a:lstStyle/>
+                    <a:p>
+                      <a:pPr algn="l">
+                        <a:spcAft>
+                          <a:spcPts val="0"/>
+                        </a:spcAft>
+                      </a:pPr>
+                      <a:r>
+                        <a:rPr lang="de-DE" sz="1600" b="0" noProof="0" dirty="0">
+                          <a:solidFill>
+                            <a:schemeClr val="tx2">
+                              <a:lumMod val="50000"/>
+                            </a:schemeClr>
+                          </a:solidFill>
+                          <a:latin typeface="Arial"/>
+                          <a:ea typeface="Times New Roman"/>
+                          <a:cs typeface="Times New Roman"/>
+                        </a:rPr>
+                        <a:t>6</a:t>
                       </a:r>
                     </a:p>
                   </a:txBody>
@@ -7611,6 +7722,39 @@
                     </a:solidFill>
                   </a:tcPr>
                 </a:tc>
+                <a:tc>
+                  <a:txBody>
+                    <a:bodyPr/>
+                    <a:lstStyle/>
+                    <a:p>
+                      <a:pPr marL="0" algn="l" defTabSz="914400" rtl="0" eaLnBrk="1" latinLnBrk="0" hangingPunct="1">
+                        <a:spcAft>
+                          <a:spcPts val="0"/>
+                        </a:spcAft>
+                      </a:pPr>
+                      <a:r>
+                        <a:rPr lang="de-DE" sz="1600" b="0" kern="1200" noProof="0" dirty="0">
+                          <a:solidFill>
+                            <a:schemeClr val="tx2">
+                              <a:lumMod val="50000"/>
+                            </a:schemeClr>
+                          </a:solidFill>
+                          <a:latin typeface="Arial"/>
+                          <a:ea typeface="Times New Roman"/>
+                          <a:cs typeface="Arial"/>
+                        </a:rPr>
+                        <a:t>7</a:t>
+                      </a:r>
+                    </a:p>
+                  </a:txBody>
+                  <a:tcPr marL="70092" marR="70092" marT="0" marB="0" anchor="ctr">
+                    <a:solidFill>
+                      <a:schemeClr val="bg1">
+                        <a:lumMod val="95000"/>
+                      </a:schemeClr>
+                    </a:solidFill>
+                  </a:tcPr>
+                </a:tc>
                 <a:extLst>
                   <a:ext uri="{0D108BD9-81ED-4DB2-BD59-A6C34878D82A}">
                     <a16:rowId xmlns:a16="http://schemas.microsoft.com/office/drawing/2014/main" val="10007"/>
@@ -7685,6 +7829,39 @@
                     </a:solidFill>
                   </a:tcPr>
                 </a:tc>
+                <a:tc>
+                  <a:txBody>
+                    <a:bodyPr/>
+                    <a:lstStyle/>
+                    <a:p>
+                      <a:pPr marL="0" algn="l" defTabSz="914400" rtl="0" eaLnBrk="1" latinLnBrk="0" hangingPunct="1">
+                        <a:spcAft>
+                          <a:spcPts val="0"/>
+                        </a:spcAft>
+                      </a:pPr>
+                      <a:r>
+                        <a:rPr lang="de-DE" sz="1600" b="0" kern="1200" noProof="0" dirty="0">
+                          <a:solidFill>
+                            <a:schemeClr val="tx2">
+                              <a:lumMod val="50000"/>
+                            </a:schemeClr>
+                          </a:solidFill>
+                          <a:latin typeface="Arial"/>
+                          <a:ea typeface="Times New Roman"/>
+                          <a:cs typeface="Arial"/>
+                        </a:rPr>
+                        <a:t>8</a:t>
+                      </a:r>
+                    </a:p>
+                  </a:txBody>
+                  <a:tcPr marL="70092" marR="70092" marT="0" marB="0" anchor="ctr">
+                    <a:solidFill>
+                      <a:schemeClr val="bg1">
+                        <a:lumMod val="95000"/>
+                      </a:schemeClr>
+                    </a:solidFill>
+                  </a:tcPr>
+                </a:tc>
                 <a:extLst>
                   <a:ext uri="{0D108BD9-81ED-4DB2-BD59-A6C34878D82A}">
                     <a16:rowId xmlns:a16="http://schemas.microsoft.com/office/drawing/2014/main" val="3141329430"/>
@@ -7769,7 +7946,12 @@
             <p:ph type="sldNum" sz="quarter" idx="10"/>
           </p:nvPr>
         </p:nvSpPr>
-        <p:spPr/>
+        <p:spPr>
+          <a:xfrm>
+            <a:off x="6827434" y="309646"/>
+            <a:ext cx="1524000" cy="283234"/>
+          </a:xfrm>
+        </p:spPr>
         <p:txBody>
           <a:bodyPr/>
           <a:lstStyle/>
@@ -7845,7 +8027,7 @@
             </a:pPr>
             <a:fld id="{5CC56EBC-D08B-471E-ACE4-D1109E130940}" type="datetime1">
               <a:rPr lang="de-DE" noProof="0" smtClean="0"/>
-              <a:t>07.08.2026</a:t>
+              <a:t>12.08.2026</a:t>
             </a:fld>
             <a:endParaRPr lang="de-DE" noProof="0" dirty="0"/>
           </a:p>
@@ -7870,57 +8052,79 @@
         <p:spPr>
           <a:xfrm>
             <a:off x="107999" y="800100"/>
-            <a:ext cx="6107529" cy="4883524"/>
+            <a:ext cx="6829350" cy="4883524"/>
           </a:xfrm>
         </p:spPr>
         <p:txBody>
           <a:bodyPr/>
           <a:lstStyle/>
           <a:p>
-            <a:pPr marL="285750" indent="-285750">
+            <a:pPr lvl="2">
+              <a:lnSpc>
+                <a:spcPct val="150000"/>
+              </a:lnSpc>
               <a:buFont typeface="Arial" panose="020B0604020202020204" pitchFamily="34" charset="0"/>
               <a:buChar char="•"/>
             </a:pPr>
-            <a:r>
-              <a:rPr lang="de-DE" noProof="0" dirty="0"/>
-              <a:t>Softwareentwickler bei </a:t>
-            </a:r>
-            <a:r>
-              <a:rPr lang="de-DE" noProof="0" dirty="0" err="1"/>
-              <a:t>Valantic</a:t>
-            </a:r>
-            <a:r>
-              <a:rPr lang="de-DE" noProof="0" dirty="0"/>
-              <a:t> STI</a:t>
-            </a:r>
-          </a:p>
-          <a:p>
-            <a:pPr marL="285750" indent="-285750">
+            <a:endParaRPr lang="de-DE" sz="2000" dirty="0"/>
+          </a:p>
+          <a:p>
+            <a:pPr lvl="2">
+              <a:lnSpc>
+                <a:spcPct val="150000"/>
+              </a:lnSpc>
               <a:buFont typeface="Arial" panose="020B0604020202020204" pitchFamily="34" charset="0"/>
               <a:buChar char="•"/>
             </a:pPr>
             <a:r>
-              <a:rPr lang="de-DE" noProof="0" dirty="0"/>
-              <a:t>Seit 2016 in der Softwareentwicklung tätig</a:t>
-            </a:r>
-          </a:p>
-          <a:p>
-            <a:pPr marL="285750" indent="-285750">
+              <a:rPr lang="de-DE" sz="2000" dirty="0"/>
+              <a:t>Softwareentwickler bei </a:t>
+            </a:r>
+            <a:r>
+              <a:rPr lang="de-DE" sz="2000" dirty="0" err="1"/>
+              <a:t>Valantic</a:t>
+            </a:r>
+            <a:r>
+              <a:rPr lang="de-DE" sz="2000" dirty="0"/>
+              <a:t> STI</a:t>
+            </a:r>
+          </a:p>
+          <a:p>
+            <a:pPr lvl="2">
+              <a:lnSpc>
+                <a:spcPct val="150000"/>
+              </a:lnSpc>
               <a:buFont typeface="Arial" panose="020B0604020202020204" pitchFamily="34" charset="0"/>
               <a:buChar char="•"/>
             </a:pPr>
             <a:r>
-              <a:rPr lang="de-DE" noProof="0" dirty="0"/>
-              <a:t>Berufsbegleitendes Studium der Wirtschaftsinformatik an der FOM</a:t>
-            </a:r>
-          </a:p>
-          <a:p>
-            <a:pPr marL="285750" indent="-285750">
+              <a:rPr lang="de-DE" sz="2000" dirty="0"/>
+              <a:t>Seit 2016 in der Softwareentwicklung tätig</a:t>
+            </a:r>
+          </a:p>
+          <a:p>
+            <a:pPr lvl="2">
+              <a:lnSpc>
+                <a:spcPct val="150000"/>
+              </a:lnSpc>
               <a:buFont typeface="Arial" panose="020B0604020202020204" pitchFamily="34" charset="0"/>
               <a:buChar char="•"/>
             </a:pPr>
             <a:r>
-              <a:rPr lang="de-DE" noProof="0" dirty="0"/>
+              <a:rPr lang="de-DE" sz="2000" dirty="0"/>
+              <a:t>Berufsbegleitendes Studium der Wirtschaftsinformatik an der FOM</a:t>
+            </a:r>
+          </a:p>
+          <a:p>
+            <a:pPr lvl="2">
+              <a:lnSpc>
+                <a:spcPct val="150000"/>
+              </a:lnSpc>
+              <a:buFont typeface="Arial" panose="020B0604020202020204" pitchFamily="34" charset="0"/>
+              <a:buChar char="•"/>
+            </a:pPr>
+            <a:r>
+              <a:rPr lang="de-DE" sz="2000" dirty="0"/>
               <a:t>Schwerpunkt: Softwareentwicklung, digitale Informationssysteme und Kundenberatung</a:t>
             </a:r>
           </a:p>
@@ -7951,6 +8155,9 @@
               <a:rPr lang="de-DE" noProof="0" dirty="0"/>
               <a:t>1. Über mich</a:t>
             </a:r>
+          </a:p>
+          <a:p>
+            <a:endParaRPr lang="de-DE" noProof="0" dirty="0"/>
           </a:p>
           <a:p>
             <a:endParaRPr lang="de-DE" noProof="0" dirty="0"/>
@@ -8073,7 +8280,12 @@
             <p:ph type="sldNum" sz="quarter" idx="10"/>
           </p:nvPr>
         </p:nvSpPr>
-        <p:spPr/>
+        <p:spPr>
+          <a:xfrm>
+            <a:off x="6832876" y="360459"/>
+            <a:ext cx="1524000" cy="283234"/>
+          </a:xfrm>
+        </p:spPr>
         <p:txBody>
           <a:bodyPr/>
           <a:lstStyle/>
@@ -8149,7 +8361,7 @@
             </a:pPr>
             <a:fld id="{5CC56EBC-D08B-471E-ACE4-D1109E130940}" type="datetime1">
               <a:rPr lang="de-DE" noProof="0" smtClean="0"/>
-              <a:t>07.08.2026</a:t>
+              <a:t>12.08.2026</a:t>
             </a:fld>
             <a:endParaRPr lang="de-DE" noProof="0" dirty="0"/>
           </a:p>
@@ -8181,52 +8393,74 @@
           <a:bodyPr/>
           <a:lstStyle/>
           <a:p>
-            <a:pPr marL="285750" indent="-285750">
+            <a:pPr lvl="2">
               <a:buFont typeface="Arial" panose="020B0604020202020204" pitchFamily="34" charset="0"/>
               <a:buChar char="•"/>
             </a:pPr>
-            <a:r>
-              <a:rPr lang="de-DE" noProof="0" dirty="0"/>
-              <a:t>Persönliche Herausforderung </a:t>
-            </a:r>
-          </a:p>
-          <a:p>
-            <a:pPr marL="285750" indent="-285750">
+            <a:endParaRPr lang="de-DE" sz="2000" dirty="0"/>
+          </a:p>
+          <a:p>
+            <a:pPr lvl="2">
+              <a:lnSpc>
+                <a:spcPct val="150000"/>
+              </a:lnSpc>
               <a:buFont typeface="Arial" panose="020B0604020202020204" pitchFamily="34" charset="0"/>
               <a:buChar char="•"/>
             </a:pPr>
             <a:r>
-              <a:rPr lang="de-DE" noProof="0" dirty="0"/>
-              <a:t>Fachliche Weiterentwicklung </a:t>
-            </a:r>
-          </a:p>
-          <a:p>
-            <a:pPr marL="285750" indent="-285750">
+              <a:rPr lang="de-DE" sz="2000" dirty="0"/>
+              <a:t>Persönliche Herausforderung </a:t>
+            </a:r>
+          </a:p>
+          <a:p>
+            <a:pPr lvl="2">
+              <a:lnSpc>
+                <a:spcPct val="150000"/>
+              </a:lnSpc>
               <a:buFont typeface="Arial" panose="020B0604020202020204" pitchFamily="34" charset="0"/>
               <a:buChar char="•"/>
             </a:pPr>
             <a:r>
-              <a:rPr lang="de-DE" noProof="0" dirty="0"/>
-              <a:t>Theorie und Praxis miteinander verbinden </a:t>
-            </a:r>
-          </a:p>
-          <a:p>
-            <a:pPr marL="285750" indent="-285750">
+              <a:rPr lang="de-DE" sz="2000" dirty="0"/>
+              <a:t>Fachliche Weiterentwicklung </a:t>
+            </a:r>
+          </a:p>
+          <a:p>
+            <a:pPr lvl="2">
+              <a:lnSpc>
+                <a:spcPct val="150000"/>
+              </a:lnSpc>
               <a:buFont typeface="Arial" panose="020B0604020202020204" pitchFamily="34" charset="0"/>
               <a:buChar char="•"/>
             </a:pPr>
             <a:r>
-              <a:rPr lang="de-DE" noProof="0" dirty="0"/>
-              <a:t>Neue Denkweisen kennenlernen</a:t>
-            </a:r>
-          </a:p>
-          <a:p>
-            <a:pPr marL="285750" indent="-285750">
+              <a:rPr lang="de-DE" sz="2000" dirty="0"/>
+              <a:t>Theorie und Praxis miteinander verbinden </a:t>
+            </a:r>
+          </a:p>
+          <a:p>
+            <a:pPr lvl="2">
+              <a:lnSpc>
+                <a:spcPct val="150000"/>
+              </a:lnSpc>
               <a:buFont typeface="Arial" panose="020B0604020202020204" pitchFamily="34" charset="0"/>
               <a:buChar char="•"/>
             </a:pPr>
             <a:r>
-              <a:rPr lang="de-DE" noProof="0" dirty="0"/>
+              <a:rPr lang="de-DE" sz="2000" dirty="0"/>
+              <a:t>Neue Denkweisen kennenlernen</a:t>
+            </a:r>
+          </a:p>
+          <a:p>
+            <a:pPr lvl="2">
+              <a:lnSpc>
+                <a:spcPct val="150000"/>
+              </a:lnSpc>
+              <a:buFont typeface="Arial" panose="020B0604020202020204" pitchFamily="34" charset="0"/>
+              <a:buChar char="•"/>
+            </a:pPr>
+            <a:r>
+              <a:rPr lang="de-DE" sz="2000" dirty="0"/>
               <a:t>Langfristige berufliche Perspektiven erweitern</a:t>
             </a:r>
           </a:p>
@@ -8308,7 +8542,7 @@
         </p:nvSpPr>
         <p:spPr>
           <a:xfrm>
-            <a:off x="7589434" y="6571896"/>
+            <a:off x="6827434" y="305597"/>
             <a:ext cx="1524000" cy="283234"/>
           </a:xfrm>
         </p:spPr>
@@ -8380,7 +8614,7 @@
                 </a:spcAft>
                 <a:defRPr/>
               </a:pPr>
-              <a:t>07.08.2026</a:t>
+              <a:t>12.08.2026</a:t>
             </a:fld>
             <a:endParaRPr lang="de-DE" noProof="0" dirty="0"/>
           </a:p>
@@ -8906,7 +9140,12 @@
             <p:ph type="sldNum" sz="quarter" idx="10"/>
           </p:nvPr>
         </p:nvSpPr>
-        <p:spPr/>
+        <p:spPr>
+          <a:xfrm>
+            <a:off x="6827434" y="309646"/>
+            <a:ext cx="1524000" cy="283234"/>
+          </a:xfrm>
+        </p:spPr>
         <p:txBody>
           <a:bodyPr/>
           <a:lstStyle/>
@@ -8982,7 +9221,7 @@
             </a:pPr>
             <a:fld id="{5CC56EBC-D08B-471E-ACE4-D1109E130940}" type="datetime1">
               <a:rPr lang="de-DE" noProof="0" smtClean="0"/>
-              <a:t>07.08.2026</a:t>
+              <a:t>12.08.2026</a:t>
             </a:fld>
             <a:endParaRPr lang="de-DE" noProof="0" dirty="0"/>
           </a:p>
@@ -9260,7 +9499,12 @@
             <p:ph type="sldNum" sz="quarter" idx="10"/>
           </p:nvPr>
         </p:nvSpPr>
-        <p:spPr/>
+        <p:spPr>
+          <a:xfrm>
+            <a:off x="6832876" y="309646"/>
+            <a:ext cx="1524000" cy="283234"/>
+          </a:xfrm>
+        </p:spPr>
         <p:txBody>
           <a:bodyPr/>
           <a:lstStyle/>
@@ -9336,7 +9580,7 @@
             </a:pPr>
             <a:fld id="{5CC56EBC-D08B-471E-ACE4-D1109E130940}" type="datetime1">
               <a:rPr lang="de-DE" noProof="0" smtClean="0"/>
-              <a:t>07.08.2026</a:t>
+              <a:t>12.08.2026</a:t>
             </a:fld>
             <a:endParaRPr lang="de-DE" noProof="0" dirty="0"/>
           </a:p>

</xml_diff>